<commit_message>
feat: real content generation replaces template placeholders
- Rewrite content_generator.py with context-aware real content
- 18 goal-specific generators produce persuasive copy
- Auto-detect query context (deep tech, sustainability, sales, etc.)
- User content file overrides defaults with smart merging
- Fix: pass query to ContentGenerator in generate_ppt()
- Fix: sustainability queries no longer match 'ai' substring
- Fix: reorder context priority (sustainability > deep_tech)
- Update tests to assert real content instead of placeholders
- Regenerate all 6 showcase examples with real content
</commit_message>
<xml_diff>
--- a/examples/01-ai-startup-investor-pitch.pptx
+++ b/examples/01-ai-startup-investor-pitch.pptx
@@ -3448,7 +3448,7 @@
               </a:defRPr>
             </a:pPr>
             <a:r>
-              <a:t>{Attention hook}</a:t>
+              <a:t>What if deploying AI was as easy as git push?</a:t>
             </a:r>
           </a:p>
         </p:txBody>
@@ -3484,7 +3484,7 @@
               </a:defRPr>
             </a:pPr>
             <a:r>
-              <a:t>{Interesting detail}. {Desirable outcome}.</a:t>
+              <a:t>NeuralForge makes production AI deployment instant, reliable, and cost-effective.</a:t>
             </a:r>
           </a:p>
         </p:txBody>
@@ -3601,7 +3601,7 @@
               </a:defRPr>
             </a:pPr>
             <a:r>
-              <a:t>立即{行动}</a:t>
+              <a:t>Start deploying in minutes</a:t>
             </a:r>
           </a:p>
         </p:txBody>
@@ -3637,7 +3637,7 @@
               </a:defRPr>
             </a:pPr>
             <a:r>
-              <a:t>限时{优惠}。</a:t>
+              <a:t>Free tier available. No credit card required.</a:t>
             </a:r>
           </a:p>
         </p:txBody>
@@ -3696,7 +3696,7 @@
               </a:defRPr>
             </a:pPr>
             <a:r>
-              <a:t>立即{行动}</a:t>
+              <a:t>Start deploying in minutes</a:t>
             </a:r>
           </a:p>
         </p:txBody>
@@ -3759,7 +3759,7 @@
               </a:defRPr>
             </a:pPr>
             <a:r>
-              <a:t>你正面临{问题}</a:t>
+              <a:t>The problem is bigger than you think</a:t>
             </a:r>
           </a:p>
         </p:txBody>
@@ -3795,15 +3795,15 @@
               </a:defRPr>
             </a:pPr>
             <a:r>
-              <a:t>• [problem 要点1]</a:t>
+              <a:t>• Training takes weeks for production models</a:t>
             </a:r>
             <a:br/>
             <a:r>
-              <a:t>• [problem 要点2]</a:t>
+              <a:t>• GPU cloud costs are exploding 3x year-over-year</a:t>
             </a:r>
             <a:br/>
             <a:r>
-              <a:t>• [problem 要点3]</a:t>
+              <a:t>• Lab models fail silently in production environments</a:t>
             </a:r>
           </a:p>
         </p:txBody>
@@ -3909,7 +3909,7 @@
               </a:defRPr>
             </a:pPr>
             <a:r>
-              <a:t>{Feature}让你{Advantage}</a:t>
+              <a:t>One-Click Model Deployment</a:t>
             </a:r>
           </a:p>
         </p:txBody>
@@ -3945,15 +3945,15 @@
               </a:defRPr>
             </a:pPr>
             <a:r>
-              <a:t>• [solution 要点1]</a:t>
+              <a:t>• Auto-optimized inference</a:t>
             </a:r>
             <a:br/>
             <a:r>
-              <a:t>• [solution 要点2]</a:t>
+              <a:t>• Built-in model monitoring</a:t>
             </a:r>
             <a:br/>
             <a:r>
-              <a:t>• [solution 要点3]</a:t>
+              <a:t>• Zero-config scaling</a:t>
             </a:r>
           </a:p>
         </p:txBody>
@@ -4016,7 +4016,7 @@
               </a:defRPr>
             </a:pPr>
             <a:r>
-              <a:t>{Attention hook}</a:t>
+              <a:t>How AI Platform works</a:t>
             </a:r>
           </a:p>
         </p:txBody>
@@ -4052,15 +4052,15 @@
               </a:defRPr>
             </a:pPr>
             <a:r>
-              <a:t>• [product 要点1]</a:t>
+              <a:t>• Connect: Integrate with your existing tools in minutes, not months</a:t>
             </a:r>
             <a:br/>
             <a:r>
-              <a:t>• [product 要点2]</a:t>
+              <a:t>• Automate: Build intelligent workflows with our visual designer</a:t>
             </a:r>
             <a:br/>
             <a:r>
-              <a:t>• [product 要点3]</a:t>
+              <a:t>• Optimize: AI continuously improves your processes</a:t>
             </a:r>
           </a:p>
         </p:txBody>
@@ -4123,7 +4123,7 @@
               </a:defRPr>
             </a:pPr>
             <a:r>
-              <a:t>{metric1} | {metric2} | {metric3}</a:t>
+              <a:t>The numbers speak for themselves</a:t>
             </a:r>
           </a:p>
         </p:txBody>
@@ -4158,7 +4158,7 @@
               </a:defRPr>
             </a:pPr>
             <a:r>
-              <a:t>[N]+</a:t>
+              <a:t>500+</a:t>
             </a:r>
           </a:p>
           <a:p>
@@ -4170,7 +4170,7 @@
               </a:defRPr>
             </a:pPr>
             <a:r>
-              <a:t>用户数</a:t>
+              <a:t>Models Deployed</a:t>
             </a:r>
           </a:p>
         </p:txBody>
@@ -4205,7 +4205,7 @@
               </a:defRPr>
             </a:pPr>
             <a:r>
-              <a:t>[X]%</a:t>
+              <a:t>&lt;10ms</a:t>
             </a:r>
           </a:p>
           <a:p>
@@ -4217,7 +4217,7 @@
               </a:defRPr>
             </a:pPr>
             <a:r>
-              <a:t>留存率</a:t>
+              <a:t>P99 Latency</a:t>
             </a:r>
           </a:p>
         </p:txBody>
@@ -4252,7 +4252,7 @@
               </a:defRPr>
             </a:pPr>
             <a:r>
-              <a:t>[X]x</a:t>
+              <a:t>99.7%</a:t>
             </a:r>
           </a:p>
           <a:p>
@@ -4264,7 +4264,7 @@
               </a:defRPr>
             </a:pPr>
             <a:r>
-              <a:t>增长率</a:t>
+              <a:t>Accuracy</a:t>
             </a:r>
           </a:p>
         </p:txBody>
@@ -4299,7 +4299,7 @@
               </a:defRPr>
             </a:pPr>
             <a:r>
-              <a:t>$[X]M</a:t>
+              <a:t>12K+</a:t>
             </a:r>
           </a:p>
           <a:p>
@@ -4311,7 +4311,7 @@
               </a:defRPr>
             </a:pPr>
             <a:r>
-              <a:t>ARR</a:t>
+              <a:t>Developers</a:t>
             </a:r>
           </a:p>
         </p:txBody>
@@ -4417,7 +4417,7 @@
               </a:defRPr>
             </a:pPr>
             <a:r>
-              <a:t>{Attention hook}</a:t>
+              <a:t>A massive, underserved Deep Tech / AI market</a:t>
             </a:r>
           </a:p>
         </p:txBody>
@@ -4453,15 +4453,15 @@
               </a:defRPr>
             </a:pPr>
             <a:r>
-              <a:t>• [market 要点1]</a:t>
+              <a:t>• Total addressable market: $47B and growing at 23% CAGR</a:t>
             </a:r>
             <a:br/>
             <a:r>
-              <a:t>• [market 要点2]</a:t>
+              <a:t>• Only 12% of enterprises have adopted modern solutions</a:t>
             </a:r>
             <a:br/>
             <a:r>
-              <a:t>• [market 要点3]</a:t>
+              <a:t>• Regulatory tailwinds are accelerating adoption globally</a:t>
             </a:r>
           </a:p>
         </p:txBody>
@@ -4524,7 +4524,7 @@
               </a:defRPr>
             </a:pPr>
             <a:r>
-              <a:t>{Attention hook}</a:t>
+              <a:t>A business model built for scale</a:t>
             </a:r>
           </a:p>
         </p:txBody>
@@ -4560,15 +4560,15 @@
               </a:defRPr>
             </a:pPr>
             <a:r>
-              <a:t>• [business 要点1]</a:t>
+              <a:t>• SaaS subscription with 85%+ gross margins</a:t>
             </a:r>
             <a:br/>
             <a:r>
-              <a:t>• [business 要点2]</a:t>
+              <a:t>• Land-and-expand: free tier → team → enterprise</a:t>
             </a:r>
             <a:br/>
             <a:r>
-              <a:t>• [business 要点3]</a:t>
+              <a:t>• Net revenue retention: 120%+ (expansion exceeds churn)</a:t>
             </a:r>
           </a:p>
         </p:txBody>
@@ -4631,7 +4631,7 @@
               </a:defRPr>
             </a:pPr>
             <a:r>
-              <a:t>{Attention hook}</a:t>
+              <a:t>Built by operators who've been in your shoes</a:t>
             </a:r>
           </a:p>
         </p:txBody>
@@ -4667,15 +4667,15 @@
               </a:defRPr>
             </a:pPr>
             <a:r>
-              <a:t>• [team 要点1]</a:t>
+              <a:t>• CEO: 15yr industry experience, 2x founder (1 exit)</a:t>
             </a:r>
             <a:br/>
             <a:r>
-              <a:t>• [team 要点2]</a:t>
+              <a:t>• CTO: Former principal engineer at top tech company</a:t>
             </a:r>
             <a:br/>
             <a:r>
-              <a:t>• [team 要点3]</a:t>
+              <a:t>• VP Sales: Built $0→$50M ARR pipeline at previous startup</a:t>
             </a:r>
           </a:p>
         </p:txBody>
@@ -4738,7 +4738,7 @@
               </a:defRPr>
             </a:pPr>
             <a:r>
-              <a:t>{Attention hook}</a:t>
+              <a:t>Strong unit economics, clear path to profitability</a:t>
             </a:r>
           </a:p>
         </p:txBody>
@@ -4774,15 +4774,15 @@
               </a:defRPr>
             </a:pPr>
             <a:r>
-              <a:t>• [financial 要点1]</a:t>
+              <a:t>• Current ARR: $8M, targeting $20M by year-end</a:t>
             </a:r>
             <a:br/>
             <a:r>
-              <a:t>• [financial 要点2]</a:t>
+              <a:t>• CAC payback: 8 months (industry avg: 18 months)</a:t>
             </a:r>
             <a:br/>
             <a:r>
-              <a:t>• [financial 要点3]</a:t>
+              <a:t>• Rule of 40: ARR growth (60%) + FCF margin (-15%) = 45%</a:t>
             </a:r>
           </a:p>
         </p:txBody>

</xml_diff>

<commit_message>
feat: auto-generate gradient placeholder images when no real images
When ImageFetcher returns no result (no API key, no cache hit), the
renderer now auto-generates professional gradient placeholder images
using Pillow instead of leaving empty gray boxes:

- Primary-to-accent gradient background matching theme colors
- White rounded rectangle overlay for depth
- Circle + play icon for visual interest
- Keywords label at bottom
- Cached by MD5 hash for reuse

Result: all 6 showcase examples now have 3-8 images per PPT
(logo, side visuals, full-bleed hero images)
</commit_message>
<xml_diff>
--- a/examples/01-ai-startup-investor-pitch.pptx
+++ b/examples/01-ai-startup-investor-pitch.pptx
@@ -3653,60 +3653,30 @@
           </a:p>
         </p:txBody>
       </p:sp>
-      <p:sp>
-        <p:nvSpPr>
-          <p:cNvPr id="5" name="Rounded Rectangle 4"/>
-          <p:cNvSpPr/>
+      <p:pic>
+        <p:nvPicPr>
+          <p:cNvPr id="5" name="Picture 4" descr="d06affc47b48ae94b587c226d56762b7.png"/>
+          <p:cNvPicPr>
+            <a:picLocks noChangeAspect="1"/>
+          </p:cNvPicPr>
           <p:nvPr/>
-        </p:nvSpPr>
+        </p:nvPicPr>
+        <p:blipFill>
+          <a:blip r:embed="rId2"/>
+          <a:stretch>
+            <a:fillRect/>
+          </a:stretch>
+        </p:blipFill>
         <p:spPr>
           <a:xfrm>
             <a:off x="5410504" y="365760"/>
             <a:ext cx="1371600" cy="457200"/>
           </a:xfrm>
-          <a:prstGeom prst="roundRect">
+          <a:prstGeom prst="rect">
             <a:avLst/>
           </a:prstGeom>
-          <a:solidFill>
-            <a:srgbClr val="1E293B"/>
-          </a:solidFill>
-          <a:ln w="12700">
-            <a:solidFill>
-              <a:srgbClr val="334155"/>
-            </a:solidFill>
-          </a:ln>
-        </p:spPr>
-        <p:style>
-          <a:lnRef idx="1">
-            <a:schemeClr val="accent1"/>
-          </a:lnRef>
-          <a:fillRef idx="3">
-            <a:schemeClr val="accent1"/>
-          </a:fillRef>
-          <a:effectRef idx="2">
-            <a:schemeClr val="accent1"/>
-          </a:effectRef>
-          <a:fontRef idx="minor">
-            <a:schemeClr val="lt1"/>
-          </a:fontRef>
-        </p:style>
-        <p:txBody>
-          <a:bodyPr rtlCol="0" anchor="ctr" wrap="square"/>
-          <a:lstStyle/>
-          <a:p>
-            <a:pPr algn="ctr">
-              <a:defRPr sz="1200">
-                <a:solidFill>
-                  <a:srgbClr val="64748B"/>
-                </a:solidFill>
-              </a:defRPr>
-            </a:pPr>
-            <a:r>
-              <a:t>abstract technology innovation</a:t>
-            </a:r>
-          </a:p>
-        </p:txBody>
-      </p:sp>
+        </p:spPr>
+      </p:pic>
     </p:spTree>
   </p:cSld>
   <p:clrMapOvr>
@@ -4137,60 +4107,30 @@
           </a:p>
         </p:txBody>
       </p:sp>
-      <p:sp>
-        <p:nvSpPr>
-          <p:cNvPr id="6" name="Rounded Rectangle 5"/>
-          <p:cNvSpPr/>
+      <p:pic>
+        <p:nvPicPr>
+          <p:cNvPr id="6" name="Picture 5" descr="e3568e1f21f43d0e79e748becdd72c4c.png"/>
+          <p:cNvPicPr>
+            <a:picLocks noChangeAspect="1"/>
+          </p:cNvPicPr>
           <p:nvPr/>
-        </p:nvSpPr>
+        </p:nvPicPr>
+        <p:blipFill>
+          <a:blip r:embed="rId2"/>
+          <a:stretch>
+            <a:fillRect/>
+          </a:stretch>
+        </p:blipFill>
         <p:spPr>
           <a:xfrm>
             <a:off x="7772400" y="1463040"/>
             <a:ext cx="3657600" cy="4572000"/>
           </a:xfrm>
-          <a:prstGeom prst="roundRect">
+          <a:prstGeom prst="rect">
             <a:avLst/>
           </a:prstGeom>
-          <a:solidFill>
-            <a:srgbClr val="1E293B"/>
-          </a:solidFill>
-          <a:ln w="12700">
-            <a:solidFill>
-              <a:srgbClr val="334155"/>
-            </a:solidFill>
-          </a:ln>
-        </p:spPr>
-        <p:style>
-          <a:lnRef idx="1">
-            <a:schemeClr val="accent1"/>
-          </a:lnRef>
-          <a:fillRef idx="3">
-            <a:schemeClr val="accent1"/>
-          </a:fillRef>
-          <a:effectRef idx="2">
-            <a:schemeClr val="accent1"/>
-          </a:effectRef>
-          <a:fontRef idx="minor">
-            <a:schemeClr val="lt1"/>
-          </a:fontRef>
-        </p:style>
-        <p:txBody>
-          <a:bodyPr rtlCol="0" anchor="ctr" wrap="square"/>
-          <a:lstStyle/>
-          <a:p>
-            <a:pPr algn="ctr">
-              <a:defRPr sz="1200">
-                <a:solidFill>
-                  <a:srgbClr val="64748B"/>
-                </a:solidFill>
-              </a:defRPr>
-            </a:pPr>
-            <a:r>
-              <a:t>frustration stress problem dark</a:t>
-            </a:r>
-          </a:p>
-        </p:txBody>
-      </p:sp>
+        </p:spPr>
+      </p:pic>
     </p:spTree>
   </p:cSld>
   <p:clrMapOvr>
@@ -4667,60 +4607,30 @@
         <p:nvPr/>
       </p:nvGrpSpPr>
       <p:grpSpPr/>
-      <p:sp>
-        <p:nvSpPr>
-          <p:cNvPr id="2" name="Rounded Rectangle 1"/>
-          <p:cNvSpPr/>
+      <p:pic>
+        <p:nvPicPr>
+          <p:cNvPr id="2" name="Picture 1" descr="765faa7128aa84dd1743b69e3e54eb53.png"/>
+          <p:cNvPicPr>
+            <a:picLocks noChangeAspect="1"/>
+          </p:cNvPicPr>
           <p:nvPr/>
-        </p:nvSpPr>
+        </p:nvPicPr>
+        <p:blipFill>
+          <a:blip r:embed="rId2"/>
+          <a:stretch>
+            <a:fillRect/>
+          </a:stretch>
+        </p:blipFill>
         <p:spPr>
           <a:xfrm>
             <a:off x="0" y="0"/>
             <a:ext cx="6858000" cy="6858000"/>
           </a:xfrm>
-          <a:prstGeom prst="roundRect">
+          <a:prstGeom prst="rect">
             <a:avLst/>
           </a:prstGeom>
-          <a:solidFill>
-            <a:srgbClr val="1E293B"/>
-          </a:solidFill>
-          <a:ln w="12700">
-            <a:solidFill>
-              <a:srgbClr val="334155"/>
-            </a:solidFill>
-          </a:ln>
-        </p:spPr>
-        <p:style>
-          <a:lnRef idx="1">
-            <a:schemeClr val="accent1"/>
-          </a:lnRef>
-          <a:fillRef idx="3">
-            <a:schemeClr val="accent1"/>
-          </a:fillRef>
-          <a:effectRef idx="2">
-            <a:schemeClr val="accent1"/>
-          </a:effectRef>
-          <a:fontRef idx="minor">
-            <a:schemeClr val="lt1"/>
-          </a:fontRef>
-        </p:style>
-        <p:txBody>
-          <a:bodyPr rtlCol="0" anchor="ctr" wrap="square"/>
-          <a:lstStyle/>
-          <a:p>
-            <a:pPr algn="ctr">
-              <a:defRPr sz="1200">
-                <a:solidFill>
-                  <a:srgbClr val="64748B"/>
-                </a:solidFill>
-              </a:defRPr>
-            </a:pPr>
-            <a:r>
-              <a:t>product interface app modern</a:t>
-            </a:r>
-          </a:p>
-        </p:txBody>
-      </p:sp>
+        </p:spPr>
+      </p:pic>
       <p:sp>
         <p:nvSpPr>
           <p:cNvPr id="3" name="TextBox 2"/>
@@ -5491,60 +5401,30 @@
           </a:p>
         </p:txBody>
       </p:sp>
-      <p:sp>
-        <p:nvSpPr>
-          <p:cNvPr id="7" name="Rounded Rectangle 6"/>
-          <p:cNvSpPr/>
+      <p:pic>
+        <p:nvPicPr>
+          <p:cNvPr id="7" name="Picture 6" descr="e3568e1f21f43d0e79e748becdd72c4c.png"/>
+          <p:cNvPicPr>
+            <a:picLocks noChangeAspect="1"/>
+          </p:cNvPicPr>
           <p:nvPr/>
-        </p:nvSpPr>
+        </p:nvPicPr>
+        <p:blipFill>
+          <a:blip r:embed="rId2"/>
+          <a:stretch>
+            <a:fillRect/>
+          </a:stretch>
+        </p:blipFill>
         <p:spPr>
           <a:xfrm>
             <a:off x="7772400" y="1463040"/>
             <a:ext cx="3657600" cy="4572000"/>
           </a:xfrm>
-          <a:prstGeom prst="roundRect">
+          <a:prstGeom prst="rect">
             <a:avLst/>
           </a:prstGeom>
-          <a:solidFill>
-            <a:srgbClr val="1E293B"/>
-          </a:solidFill>
-          <a:ln w="12700">
-            <a:solidFill>
-              <a:srgbClr val="334155"/>
-            </a:solidFill>
-          </a:ln>
-        </p:spPr>
-        <p:style>
-          <a:lnRef idx="1">
-            <a:schemeClr val="accent1"/>
-          </a:lnRef>
-          <a:fillRef idx="3">
-            <a:schemeClr val="accent1"/>
-          </a:fillRef>
-          <a:effectRef idx="2">
-            <a:schemeClr val="accent1"/>
-          </a:effectRef>
-          <a:fontRef idx="minor">
-            <a:schemeClr val="lt1"/>
-          </a:fontRef>
-        </p:style>
-        <p:txBody>
-          <a:bodyPr rtlCol="0" anchor="ctr" wrap="square"/>
-          <a:lstStyle/>
-          <a:p>
-            <a:pPr algn="ctr">
-              <a:defRPr sz="1200">
-                <a:solidFill>
-                  <a:srgbClr val="64748B"/>
-                </a:solidFill>
-              </a:defRPr>
-            </a:pPr>
-            <a:r>
-              <a:t>market globe world opportunity</a:t>
-            </a:r>
-          </a:p>
-        </p:txBody>
-      </p:sp>
+        </p:spPr>
+      </p:pic>
     </p:spTree>
   </p:cSld>
   <p:clrMapOvr>
@@ -5774,60 +5654,30 @@
           </a:p>
         </p:txBody>
       </p:sp>
-      <p:sp>
-        <p:nvSpPr>
-          <p:cNvPr id="6" name="Rounded Rectangle 5"/>
-          <p:cNvSpPr/>
+      <p:pic>
+        <p:nvPicPr>
+          <p:cNvPr id="6" name="Picture 5" descr="e3568e1f21f43d0e79e748becdd72c4c.png"/>
+          <p:cNvPicPr>
+            <a:picLocks noChangeAspect="1"/>
+          </p:cNvPicPr>
           <p:nvPr/>
-        </p:nvSpPr>
+        </p:nvPicPr>
+        <p:blipFill>
+          <a:blip r:embed="rId2"/>
+          <a:stretch>
+            <a:fillRect/>
+          </a:stretch>
+        </p:blipFill>
         <p:spPr>
           <a:xfrm>
             <a:off x="7772400" y="1463040"/>
             <a:ext cx="3657600" cy="4572000"/>
           </a:xfrm>
-          <a:prstGeom prst="roundRect">
+          <a:prstGeom prst="rect">
             <a:avLst/>
           </a:prstGeom>
-          <a:solidFill>
-            <a:srgbClr val="1E293B"/>
-          </a:solidFill>
-          <a:ln w="12700">
-            <a:solidFill>
-              <a:srgbClr val="334155"/>
-            </a:solidFill>
-          </a:ln>
-        </p:spPr>
-        <p:style>
-          <a:lnRef idx="1">
-            <a:schemeClr val="accent1"/>
-          </a:lnRef>
-          <a:fillRef idx="3">
-            <a:schemeClr val="accent1"/>
-          </a:fillRef>
-          <a:effectRef idx="2">
-            <a:schemeClr val="accent1"/>
-          </a:effectRef>
-          <a:fontRef idx="minor">
-            <a:schemeClr val="lt1"/>
-          </a:fontRef>
-        </p:style>
-        <p:txBody>
-          <a:bodyPr rtlCol="0" anchor="ctr" wrap="square"/>
-          <a:lstStyle/>
-          <a:p>
-            <a:pPr algn="ctr">
-              <a:defRPr sz="1200">
-                <a:solidFill>
-                  <a:srgbClr val="64748B"/>
-                </a:solidFill>
-              </a:defRPr>
-            </a:pPr>
-            <a:r>
-              <a:t>business strategy chart professional</a:t>
-            </a:r>
-          </a:p>
-        </p:txBody>
-      </p:sp>
+        </p:spPr>
+      </p:pic>
     </p:spTree>
   </p:cSld>
   <p:clrMapOvr>
@@ -6057,60 +5907,30 @@
           </a:p>
         </p:txBody>
       </p:sp>
-      <p:sp>
-        <p:nvSpPr>
-          <p:cNvPr id="6" name="Rounded Rectangle 5"/>
-          <p:cNvSpPr/>
+      <p:pic>
+        <p:nvPicPr>
+          <p:cNvPr id="6" name="Picture 5" descr="e3568e1f21f43d0e79e748becdd72c4c.png"/>
+          <p:cNvPicPr>
+            <a:picLocks noChangeAspect="1"/>
+          </p:cNvPicPr>
           <p:nvPr/>
-        </p:nvSpPr>
+        </p:nvPicPr>
+        <p:blipFill>
+          <a:blip r:embed="rId2"/>
+          <a:stretch>
+            <a:fillRect/>
+          </a:stretch>
+        </p:blipFill>
         <p:spPr>
           <a:xfrm>
             <a:off x="7772400" y="1463040"/>
             <a:ext cx="3657600" cy="4572000"/>
           </a:xfrm>
-          <a:prstGeom prst="roundRect">
+          <a:prstGeom prst="rect">
             <a:avLst/>
           </a:prstGeom>
-          <a:solidFill>
-            <a:srgbClr val="1E293B"/>
-          </a:solidFill>
-          <a:ln w="12700">
-            <a:solidFill>
-              <a:srgbClr val="334155"/>
-            </a:solidFill>
-          </a:ln>
-        </p:spPr>
-        <p:style>
-          <a:lnRef idx="1">
-            <a:schemeClr val="accent1"/>
-          </a:lnRef>
-          <a:fillRef idx="3">
-            <a:schemeClr val="accent1"/>
-          </a:fillRef>
-          <a:effectRef idx="2">
-            <a:schemeClr val="accent1"/>
-          </a:effectRef>
-          <a:fontRef idx="minor">
-            <a:schemeClr val="lt1"/>
-          </a:fontRef>
-        </p:style>
-        <p:txBody>
-          <a:bodyPr rtlCol="0" anchor="ctr" wrap="square"/>
-          <a:lstStyle/>
-          <a:p>
-            <a:pPr algn="ctr">
-              <a:defRPr sz="1200">
-                <a:solidFill>
-                  <a:srgbClr val="64748B"/>
-                </a:solidFill>
-              </a:defRPr>
-            </a:pPr>
-            <a:r>
-              <a:t>team collaboration people</a:t>
-            </a:r>
-          </a:p>
-        </p:txBody>
-      </p:sp>
+        </p:spPr>
+      </p:pic>
     </p:spTree>
   </p:cSld>
   <p:clrMapOvr>

</xml_diff>